<commit_message>
場景編號: 場景 1 PPT 第一頁 (project3)、場景 2 長牆 (corridor)、場景 3 論文 (paper_fig4)、場景 4 柱子 (clutter)
README / SETUP / 專案說明 / results / 簡報統一用這組編號; 指令裡的名稱不變

Co-Authored-By: Claude Opus 5.5 <noreply@anthropic.com>
</commit_message>
<xml_diff>
--- a/docs/DOGZILLA_專案簡報.pptx
+++ b/docs/DOGZILLA_專案簡報.pptx
@@ -1304,7 +1304,12 @@
           <a:lstStyle/>
           <a:p>
             <a:r>
-              <a:t>這是新的預設測試場地，比投影片第一頁的場景難很多。</a:t>
+              <a:t>測試場景一共四個。場景 1 是投影片第一頁的原始場景，最簡單；場景 2 是長牆，也是預設場景，就是這張圖；場景 3 是照一篇論文的地圖建的；場景 4 是密集的柱子。</a:t>
+            </a:r>
+          </a:p>
+          <a:p>
+            <a:r>
+              <a:t>先看圖上的場景 2，它比場景 1 難很多。</a:t>
             </a:r>
           </a:p>
           <a:p>
@@ -1324,7 +1329,7 @@
           </a:p>
           <a:p>
             <a:r>
-              <a:t>另外還有兩個場地：一個是 21 根柱子交錯排列的密集障礙物場地；一個是照一篇四足機器人路徑規劃論文的地圖建的，10 公尺見方，有 16 塊障礙物和論文裡提到的 L 形陷阱。</a:t>
+              <a:t>場景 3 是照一篇四足機器人路徑規劃論文的地圖建的，10 公尺見方，有 16 塊障礙物和論文裡提到的 L 形陷阱；場景 4 是 21 根柱子交錯排列的密集障礙物場地。</a:t>
             </a:r>
           </a:p>
           <a:p>
@@ -5441,7 +5446,7 @@
                           <a:ea typeface="Microsoft JhengHei"/>
                           <a:cs typeface="Microsoft JhengHei"/>
                         </a:rPr>
-                        <a:t>場地 / 避障方法</a:t>
+                        <a:t>場景 / 避障方法</a:t>
                       </a:r>
                     </a:p>
                   </a:txBody>
@@ -5568,7 +5573,7 @@
                           <a:ea typeface="Microsoft JhengHei"/>
                           <a:cs typeface="Microsoft JhengHei"/>
                         </a:rPr>
-                        <a:t>窄通道：強化學習（目前）</a:t>
+                        <a:t>場景 2 長牆：強化學習（目前）</a:t>
                       </a:r>
                     </a:p>
                   </a:txBody>
@@ -5695,7 +5700,7 @@
                           <a:ea typeface="Microsoft JhengHei"/>
                           <a:cs typeface="Microsoft JhengHei"/>
                         </a:rPr>
-                        <a:t>密集柱子：強化學習（目前）</a:t>
+                        <a:t>場景 4 柱子：強化學習（目前）</a:t>
                       </a:r>
                     </a:p>
                   </a:txBody>
@@ -5822,7 +5827,7 @@
                           <a:ea typeface="Microsoft JhengHei"/>
                           <a:cs typeface="Microsoft JhengHei"/>
                         </a:rPr>
-                        <a:t>窄通道：Nav2 RPP</a:t>
+                        <a:t>場景 2 長牆：Nav2 RPP</a:t>
                       </a:r>
                     </a:p>
                   </a:txBody>
@@ -6062,7 +6067,7 @@
                 <a:ea typeface="Microsoft JhengHei"/>
                 <a:cs typeface="Microsoft JhengHei"/>
               </a:rPr>
-              <a:t>•  各為單次執行；用模擬器的真實位置評分</a:t>
+              <a:t>•  場景 3 論文：強化學習 4 / 5（通道較寬，走得到但繞路）；場景 1：Nav2 RPP 1 / 7。各為單次執行</a:t>
             </a:r>
           </a:p>
         </p:txBody>
@@ -14603,7 +14608,7 @@
                 <a:ea typeface="Microsoft JhengHei"/>
                 <a:cs typeface="Microsoft JhengHei"/>
               </a:rPr>
-              <a:t>測試場地：比投影片場景更難</a:t>
+              <a:t>測試場景：四個場景，圖為場景 2 長牆</a:t>
             </a:r>
           </a:p>
         </p:txBody>
@@ -14682,7 +14687,7 @@
                 <a:ea typeface="Microsoft JhengHei"/>
                 <a:cs typeface="Microsoft JhengHei"/>
               </a:rPr>
-              <a:t>預設場地：蛇行繞過兩道長牆、穿過 0.6 m 的門口、門後還有死巷；連續走 7 個目標點</a:t>
+              <a:t>場景 1 PPT 第一頁｜場景 2 長牆（預設）｜場景 3 論文地圖｜場景 4 柱子；每個場景連續走多個目標點</a:t>
             </a:r>
           </a:p>
         </p:txBody>
@@ -15181,7 +15186,7 @@
                 <a:ea typeface="Microsoft JhengHei"/>
                 <a:cs typeface="Microsoft JhengHei"/>
               </a:rPr>
-              <a:t>目前的強化學習策略到達的目標數</a:t>
+              <a:t>目前的強化學習策略在場景 2 到達的目標數</a:t>
             </a:r>
           </a:p>
         </p:txBody>
@@ -15225,7 +15230,7 @@
                 <a:ea typeface="Microsoft JhengHei"/>
                 <a:cs typeface="Microsoft JhengHei"/>
               </a:rPr>
-              <a:t>藍線：目前的策略（只訓練 10 萬步）走過的路徑，卡在 0.6 m 的門口前。另有密集柱子與論文地圖兩個場地</a:t>
+              <a:t>場景 2：蛇行繞過兩道長牆、穿過 0.6 m 的門口、門後有死巷。藍線是目前的策略走過的路徑，卡在門口前</a:t>
             </a:r>
           </a:p>
         </p:txBody>

</xml_diff>